<commit_message>
Change third pinned-post cover to model house open-house
Co-Authored-By: Claude Opus 5.5 <noreply@anthropic.com>
Claude-Session: https://claude.ai/code/session_012B9C5ZEN3wmcNpkXGGwKaW
</commit_message>
<xml_diff>
--- a/instagram/Instagram固定投稿イメージ.pptx
+++ b/instagram/Instagram固定投稿イメージ.pptx
@@ -1432,7 +1432,7 @@
                   <a:schemeClr val="tx1"/>
                 </a:solidFill>
               </a:rPr>
-              <a:t>実例紹介</a:t>
+              <a:t>モデルハウス見学会</a:t>
             </a:r>
             <a:endParaRPr lang="en-US" sz="1100" dirty="0"/>
           </a:p>
@@ -1449,7 +1449,7 @@
                   <a:schemeClr val="tx2"/>
                 </a:solidFill>
               </a:rPr>
-              <a:t>外観・ガレージ・室内</a:t>
+              <a:t>古河展示場・実例紹介</a:t>
             </a:r>
             <a:endParaRPr lang="en-US" sz="1100" dirty="0"/>
           </a:p>

</xml_diff>